<commit_message>
fix(demo): improve PPTX text fill contrast
Compare vivid gold, pale gold and white text on a dark background. Keep the gradient midpoint approximation explicit in the sample and preserve the focused color regression fixture.

Tested: 14 focused Rust tests; rustfmt; clippy; Android debug builds; demo-samples on device in portrait and landscape
</commit_message>
<xml_diff>
--- a/demo/src/main/assets/samples/sample.pptx
+++ b/demo/src/main/assets/samples/sample.pptx
@@ -2946,25 +2946,25 @@
 </file>
 
 <file path=ppt/showcase/colors/slides/slide1.xml><?xml version="1.0" encoding="utf-8"?>
-<p:sld xmlns:p="http://schemas.openxmlformats.org/presentationml/2006/main" xmlns:a="http://schemas.openxmlformats.org/drawingml/2006/main" xmlns:r="http://schemas.openxmlformats.org/officeDocument/2006/relationships">
+<p:sld xmlns:p="http://schemas.openxmlformats.org/presentationml/2006/main" xmlns:a="http://schemas.openxmlformats.org/drawingml/2006/main">
   <p:cSld>
     <p:bg>
       <p:bgPr>
         <a:solidFill>
-          <a:srgbClr val="FF0000"/>
+          <a:srgbClr val="172B46"/>
         </a:solidFill>
       </p:bgPr>
     </p:bg>
     <p:spTree>
       <p:nvGrpSpPr>
-        <p:cNvPr id="3" name="Showcase canvas"/>
+        <p:cNvPr id="8" name="Showcase canvas"/>
         <p:cNvGrpSpPr/>
         <p:nvPr/>
       </p:nvGrpSpPr>
       <p:grpSpPr/>
       <p:grpSp>
         <p:nvGrpSpPr>
-          <p:cNvPr id="4" name="Source slide, centered"/>
+          <p:cNvPr id="9" name="Source slide, centered"/>
           <p:cNvGrpSpPr/>
           <p:nvPr/>
         </p:nvGrpSpPr>
@@ -2978,34 +2978,168 @@
         </p:grpSpPr>
         <p:sp>
           <p:nvSpPr>
-            <p:cNvPr id="2" name="Gold title"/>
-            <p:cNvSpPr txBox="1"/>
-            <p:nvPr/>
-          </p:nvSpPr>
-          <p:spPr>
-            <a:xfrm>
-              <a:off x="1171222" y="1171222"/>
-              <a:ext cx="6090356" cy="1639711"/>
-            </a:xfrm>
-            <a:prstGeom prst="rect">
-              <a:avLst/>
-            </a:prstGeom>
-            <a:noFill/>
-            <a:ln>
-              <a:noFill/>
-            </a:ln>
+            <p:cNvPr id="2" name="Text color comparison"/>
+            <p:cNvSpPr txBox="1"/>
+            <p:nvPr/>
+          </p:nvSpPr>
+          <p:spPr>
+            <a:xfrm>
+              <a:off x="468489" y="234244"/>
+              <a:ext cx="7495822" cy="843280"/>
+            </a:xfrm>
+            <a:noFill/>
           </p:spPr>
           <p:txBody>
             <a:bodyPr lIns="0" rIns="0" tIns="0" bIns="0"/>
             <a:lstStyle/>
             <a:p>
               <a:r>
-                <a:rPr lang="en-US" sz="5902">
+                <a:rPr sz="1844" b="0">
+                  <a:solidFill>
+                    <a:srgbClr val="C3D1E0"/>
+                  </a:solidFill>
+                </a:rPr>
+                <a:t>亮金色 · #FFC852</a:t>
+              </a:r>
+            </a:p>
+          </p:txBody>
+        </p:sp>
+        <p:sp>
+          <p:nvSpPr>
+            <p:cNvPr id="3" name="Text color comparison"/>
+            <p:cNvSpPr txBox="1"/>
+            <p:nvPr/>
+          </p:nvSpPr>
+          <p:spPr>
+            <a:xfrm>
+              <a:off x="468489" y="585611"/>
+              <a:ext cx="7495822" cy="843280"/>
+            </a:xfrm>
+            <a:noFill/>
+          </p:spPr>
+          <p:txBody>
+            <a:bodyPr lIns="0" rIns="0" tIns="0" bIns="0"/>
+            <a:lstStyle/>
+            <a:p>
+              <a:r>
+                <a:rPr sz="4796" b="1">
+                  <a:solidFill>
+                    <a:srgbClr val="FFC852"/>
+                  </a:solidFill>
+                </a:rPr>
+                <a:t>文字填色 Aa 123</a:t>
+              </a:r>
+            </a:p>
+          </p:txBody>
+        </p:sp>
+        <p:sp>
+          <p:nvSpPr>
+            <p:cNvPr id="4" name="Text color comparison"/>
+            <p:cNvSpPr txBox="1"/>
+            <p:nvPr/>
+          </p:nvSpPr>
+          <p:spPr>
+            <a:xfrm>
+              <a:off x="468489" y="1709984"/>
+              <a:ext cx="7495822" cy="843280"/>
+            </a:xfrm>
+            <a:noFill/>
+          </p:spPr>
+          <p:txBody>
+            <a:bodyPr lIns="0" rIns="0" tIns="0" bIns="0"/>
+            <a:lstStyle/>
+            <a:p>
+              <a:r>
+                <a:rPr sz="1844" b="0">
+                  <a:solidFill>
+                    <a:srgbClr val="C3D1E0"/>
+                  </a:solidFill>
+                </a:rPr>
+                <a:t>浅金色 · #FFF3DD</a:t>
+              </a:r>
+            </a:p>
+          </p:txBody>
+        </p:sp>
+        <p:sp>
+          <p:nvSpPr>
+            <p:cNvPr id="5" name="Text color comparison"/>
+            <p:cNvSpPr txBox="1"/>
+            <p:nvPr/>
+          </p:nvSpPr>
+          <p:spPr>
+            <a:xfrm>
+              <a:off x="468489" y="2061351"/>
+              <a:ext cx="7495822" cy="843280"/>
+            </a:xfrm>
+            <a:noFill/>
+          </p:spPr>
+          <p:txBody>
+            <a:bodyPr lIns="0" rIns="0" tIns="0" bIns="0"/>
+            <a:lstStyle/>
+            <a:p>
+              <a:r>
+                <a:rPr sz="4796" b="1">
                   <a:solidFill>
                     <a:srgbClr val="FFF3DD"/>
                   </a:solidFill>
                 </a:rPr>
-                <a:t>Gold title</a:t>
+                <a:t>文字填色 Aa 123</a:t>
+              </a:r>
+            </a:p>
+          </p:txBody>
+        </p:sp>
+        <p:sp>
+          <p:nvSpPr>
+            <p:cNvPr id="6" name="Text color comparison"/>
+            <p:cNvSpPr txBox="1"/>
+            <p:nvPr/>
+          </p:nvSpPr>
+          <p:spPr>
+            <a:xfrm>
+              <a:off x="468489" y="3185724"/>
+              <a:ext cx="7495822" cy="843280"/>
+            </a:xfrm>
+            <a:noFill/>
+          </p:spPr>
+          <p:txBody>
+            <a:bodyPr lIns="0" rIns="0" tIns="0" bIns="0"/>
+            <a:lstStyle/>
+            <a:p>
+              <a:r>
+                <a:rPr sz="1844" b="0">
+                  <a:solidFill>
+                    <a:srgbClr val="C3D1E0"/>
+                  </a:solidFill>
+                </a:rPr>
+                <a:t>白色参照 · #FFFFFF</a:t>
+              </a:r>
+            </a:p>
+          </p:txBody>
+        </p:sp>
+        <p:sp>
+          <p:nvSpPr>
+            <p:cNvPr id="7" name="Text color comparison"/>
+            <p:cNvSpPr txBox="1"/>
+            <p:nvPr/>
+          </p:nvSpPr>
+          <p:spPr>
+            <a:xfrm>
+              <a:off x="468489" y="3537091"/>
+              <a:ext cx="7495822" cy="843280"/>
+            </a:xfrm>
+            <a:noFill/>
+          </p:spPr>
+          <p:txBody>
+            <a:bodyPr lIns="0" rIns="0" tIns="0" bIns="0"/>
+            <a:lstStyle/>
+            <a:p>
+              <a:r>
+                <a:rPr sz="4796" b="1">
+                  <a:solidFill>
+                    <a:srgbClr val="FFFFFF"/>
+                  </a:solidFill>
+                </a:rPr>
+                <a:t>文字填色 Aa 123</a:t>
               </a:r>
             </a:p>
           </p:txBody>
@@ -3013,7 +3147,7 @@
       </p:grpSp>
       <p:sp>
         <p:nvSpPr>
-          <p:cNvPr id="5" name="Showcase explanation"/>
+          <p:cNvPr id="10" name="Showcase explanation"/>
           <p:cNvSpPr txBox="1"/>
           <p:nvPr/>
         </p:nvSpPr>
@@ -3045,14 +3179,14 @@
                   <a:srgbClr val="FFFFFF"/>
                 </a:solidFill>
               </a:rPr>
-              <a:t>文字填色 · 纯色参照</a:t>
+              <a:t>文字填色 · 亮金与浅金对照</a:t>
             </a:r>
           </a:p>
         </p:txBody>
       </p:sp>
       <p:sp>
         <p:nvSpPr>
-          <p:cNvPr id="6" name="Showcase explanation"/>
+          <p:cNvPr id="11" name="Showcase explanation"/>
           <p:cNvSpPr txBox="1"/>
           <p:nvPr/>
         </p:nvSpPr>
@@ -3102,9 +3236,9 @@
                   <a:srgbClr val="102238"/>
                 </a:solidFill>
               </a:rPr>
-              <a:t>相同文字指定纯色
-色值为 FFF3DD
-不使用渐变或主题色</a:t>
+              <a:t>同样文字、字号和背景
+依次使用亮金、浅金
+和白色三种纯色</a:t>
             </a:r>
           </a:p>
           <a:p>
@@ -3140,16 +3274,16 @@
                   <a:srgbClr val="102238"/>
                 </a:solidFill>
               </a:rPr>
-              <a:t>浅金色文字接近前页
-输入不同，显示应接近
-用于核对代表色解析</a:t>
+              <a:t>亮金色应明显偏黄
+浅金色较接近白色
+对照可见填色差别</a:t>
             </a:r>
           </a:p>
         </p:txBody>
       </p:sp>
       <p:sp>
         <p:nvSpPr>
-          <p:cNvPr id="7" name="Example boundary"/>
+          <p:cNvPr id="12" name="Example boundary"/>
           <p:cNvSpPr/>
           <p:nvPr/>
         </p:nvSpPr>
@@ -3176,25 +3310,25 @@
 </file>
 
 <file path=ppt/showcase/colors/slides/slide2.xml><?xml version="1.0" encoding="utf-8"?>
-<p:sld xmlns:p="http://schemas.openxmlformats.org/presentationml/2006/main" xmlns:a="http://schemas.openxmlformats.org/drawingml/2006/main" xmlns:r="http://schemas.openxmlformats.org/officeDocument/2006/relationships">
+<p:sld xmlns:p="http://schemas.openxmlformats.org/presentationml/2006/main" xmlns:a="http://schemas.openxmlformats.org/drawingml/2006/main">
   <p:cSld>
     <p:bg>
       <p:bgPr>
         <a:solidFill>
-          <a:srgbClr val="FF0000"/>
+          <a:srgbClr val="172B46"/>
         </a:solidFill>
       </p:bgPr>
     </p:bg>
     <p:spTree>
       <p:nvGrpSpPr>
-        <p:cNvPr id="3" name="Showcase canvas"/>
+        <p:cNvPr id="8" name="Showcase canvas"/>
         <p:cNvGrpSpPr/>
         <p:nvPr/>
       </p:nvGrpSpPr>
       <p:grpSpPr/>
       <p:grpSp>
         <p:nvGrpSpPr>
-          <p:cNvPr id="4" name="Source slide, centered"/>
+          <p:cNvPr id="9" name="Source slide, centered"/>
           <p:cNvGrpSpPr/>
           <p:nvPr/>
         </p:nvGrpSpPr>
@@ -3208,45 +3342,176 @@
         </p:grpSpPr>
         <p:sp>
           <p:nvSpPr>
-            <p:cNvPr id="2" name="Gold title"/>
-            <p:cNvSpPr txBox="1"/>
-            <p:nvPr/>
-          </p:nvSpPr>
-          <p:spPr>
-            <a:xfrm>
-              <a:off x="1171222" y="1171222"/>
-              <a:ext cx="6090356" cy="1639711"/>
-            </a:xfrm>
-            <a:prstGeom prst="rect">
-              <a:avLst/>
-            </a:prstGeom>
-            <a:noFill/>
-            <a:ln>
-              <a:noFill/>
-            </a:ln>
+            <p:cNvPr id="2" name="Text color comparison"/>
+            <p:cNvSpPr txBox="1"/>
+            <p:nvPr/>
+          </p:nvSpPr>
+          <p:spPr>
+            <a:xfrm>
+              <a:off x="468489" y="234244"/>
+              <a:ext cx="7495822" cy="843280"/>
+            </a:xfrm>
+            <a:noFill/>
           </p:spPr>
           <p:txBody>
             <a:bodyPr lIns="0" rIns="0" tIns="0" bIns="0"/>
             <a:lstStyle/>
             <a:p>
               <a:r>
-                <a:rPr lang="en-US" sz="5902">
+                <a:rPr sz="1844" b="0">
+                  <a:solidFill>
+                    <a:srgbClr val="C3D1E0"/>
+                  </a:solidFill>
+                </a:rPr>
+                <a:t>渐变输入 · 中点色预览</a:t>
+              </a:r>
+            </a:p>
+          </p:txBody>
+        </p:sp>
+        <p:sp>
+          <p:nvSpPr>
+            <p:cNvPr id="3" name="Text color comparison"/>
+            <p:cNvSpPr txBox="1"/>
+            <p:nvPr/>
+          </p:nvSpPr>
+          <p:spPr>
+            <a:xfrm>
+              <a:off x="468489" y="585611"/>
+              <a:ext cx="7495822" cy="843280"/>
+            </a:xfrm>
+            <a:noFill/>
+          </p:spPr>
+          <p:txBody>
+            <a:bodyPr lIns="0" rIns="0" tIns="0" bIns="0"/>
+            <a:lstStyle/>
+            <a:p>
+              <a:r>
+                <a:rPr sz="4796" b="1">
                   <a:gradFill>
                     <a:gsLst>
-                      <a:gs pos="30000">
-                        <a:srgbClr val="FFFAEB"/>
+                      <a:gs pos="0">
+                        <a:srgbClr val="FFD54F"/>
                       </a:gs>
                       <a:gs pos="100000">
-                        <a:schemeClr val="accent4">
-                          <a:lumMod val="40000"/>
-                          <a:lumOff val="60000"/>
-                        </a:schemeClr>
+                        <a:schemeClr val="accent4"/>
                       </a:gs>
                     </a:gsLst>
                     <a:lin ang="5400000" scaled="0"/>
                   </a:gradFill>
                 </a:rPr>
-                <a:t>Gold title</a:t>
+                <a:t>文字填色 Aa 123</a:t>
+              </a:r>
+            </a:p>
+          </p:txBody>
+        </p:sp>
+        <p:sp>
+          <p:nvSpPr>
+            <p:cNvPr id="4" name="Text color comparison"/>
+            <p:cNvSpPr txBox="1"/>
+            <p:nvPr/>
+          </p:nvSpPr>
+          <p:spPr>
+            <a:xfrm>
+              <a:off x="468489" y="1709984"/>
+              <a:ext cx="7495822" cy="843280"/>
+            </a:xfrm>
+            <a:noFill/>
+          </p:spPr>
+          <p:txBody>
+            <a:bodyPr lIns="0" rIns="0" tIns="0" bIns="0"/>
+            <a:lstStyle/>
+            <a:p>
+              <a:r>
+                <a:rPr sz="1844" b="0">
+                  <a:solidFill>
+                    <a:srgbClr val="C3D1E0"/>
+                  </a:solidFill>
+                </a:rPr>
+                <a:t>等效纯色 · #FFC852</a:t>
+              </a:r>
+            </a:p>
+          </p:txBody>
+        </p:sp>
+        <p:sp>
+          <p:nvSpPr>
+            <p:cNvPr id="5" name="Text color comparison"/>
+            <p:cNvSpPr txBox="1"/>
+            <p:nvPr/>
+          </p:nvSpPr>
+          <p:spPr>
+            <a:xfrm>
+              <a:off x="468489" y="2061351"/>
+              <a:ext cx="7495822" cy="843280"/>
+            </a:xfrm>
+            <a:noFill/>
+          </p:spPr>
+          <p:txBody>
+            <a:bodyPr lIns="0" rIns="0" tIns="0" bIns="0"/>
+            <a:lstStyle/>
+            <a:p>
+              <a:r>
+                <a:rPr sz="4796" b="1">
+                  <a:solidFill>
+                    <a:srgbClr val="FFC852"/>
+                  </a:solidFill>
+                </a:rPr>
+                <a:t>文字填色 Aa 123</a:t>
+              </a:r>
+            </a:p>
+          </p:txBody>
+        </p:sp>
+        <p:sp>
+          <p:nvSpPr>
+            <p:cNvPr id="6" name="Text color comparison"/>
+            <p:cNvSpPr txBox="1"/>
+            <p:nvPr/>
+          </p:nvSpPr>
+          <p:spPr>
+            <a:xfrm>
+              <a:off x="468489" y="3185724"/>
+              <a:ext cx="7495822" cy="843280"/>
+            </a:xfrm>
+            <a:noFill/>
+          </p:spPr>
+          <p:txBody>
+            <a:bodyPr lIns="0" rIns="0" tIns="0" bIns="0"/>
+            <a:lstStyle/>
+            <a:p>
+              <a:r>
+                <a:rPr sz="1844" b="0">
+                  <a:solidFill>
+                    <a:srgbClr val="C3D1E0"/>
+                  </a:solidFill>
+                </a:rPr>
+                <a:t>白色参照 · #FFFFFF</a:t>
+              </a:r>
+            </a:p>
+          </p:txBody>
+        </p:sp>
+        <p:sp>
+          <p:nvSpPr>
+            <p:cNvPr id="7" name="Text color comparison"/>
+            <p:cNvSpPr txBox="1"/>
+            <p:nvPr/>
+          </p:nvSpPr>
+          <p:spPr>
+            <a:xfrm>
+              <a:off x="468489" y="3537091"/>
+              <a:ext cx="7495822" cy="843280"/>
+            </a:xfrm>
+            <a:noFill/>
+          </p:spPr>
+          <p:txBody>
+            <a:bodyPr lIns="0" rIns="0" tIns="0" bIns="0"/>
+            <a:lstStyle/>
+            <a:p>
+              <a:r>
+                <a:rPr sz="4796" b="1">
+                  <a:solidFill>
+                    <a:srgbClr val="FFFFFF"/>
+                  </a:solidFill>
+                </a:rPr>
+                <a:t>文字填色 Aa 123</a:t>
               </a:r>
             </a:p>
           </p:txBody>
@@ -3254,7 +3519,7 @@
       </p:grpSp>
       <p:sp>
         <p:nvSpPr>
-          <p:cNvPr id="5" name="Showcase explanation"/>
+          <p:cNvPr id="10" name="Showcase explanation"/>
           <p:cNvSpPr txBox="1"/>
           <p:nvPr/>
         </p:nvSpPr>
@@ -3286,14 +3551,14 @@
                   <a:srgbClr val="FFFFFF"/>
                 </a:solidFill>
               </a:rPr>
-              <a:t>文字填色 · 渐变输入</a:t>
+              <a:t>文字填色 · 渐变与纯色对照</a:t>
             </a:r>
           </a:p>
         </p:txBody>
       </p:sp>
       <p:sp>
         <p:nvSpPr>
-          <p:cNvPr id="6" name="Showcase explanation"/>
+          <p:cNvPr id="11" name="Showcase explanation"/>
           <p:cNvSpPr txBox="1"/>
           <p:nvPr/>
         </p:nvSpPr>
@@ -3343,9 +3608,9 @@
                   <a:srgbClr val="102238"/>
                 </a:solidFill>
               </a:rPr>
-              <a:t>文字声明金色渐变
-一个色标来自主题色
-并叠加亮度变换</a:t>
+              <a:t>上：金色渐变输入
+中：等效亮金色纯色
+下：白色文字参照</a:t>
             </a:r>
           </a:p>
           <a:p>
@@ -3381,16 +3646,17 @@
                   <a:srgbClr val="102238"/>
                 </a:solidFill>
               </a:rPr>
-              <a:t>当前使用浅金色代表色
-未逐像素绘制文字渐变
-应接近下一页纯色参照</a:t>
+              <a:t>上、中两行颜色一致
+与下方白字明显区分
+渐变按中点纯色显示
+暂不呈现字内渐变</a:t>
             </a:r>
           </a:p>
         </p:txBody>
       </p:sp>
       <p:sp>
         <p:nvSpPr>
-          <p:cNvPr id="7" name="Example boundary"/>
+          <p:cNvPr id="12" name="Example boundary"/>
           <p:cNvSpPr/>
           <p:nvPr/>
         </p:nvSpPr>

</xml_diff>

<commit_message>
feat(demo): expand samples with compatibility examples
Add DOCX font inheritance, PPTX numbering and preset shape pages, and XLSX palette and tint comparisons to the existing generated samples. Preserve the original content and document where to find each example.

Tested: 14 focused Rust tests, workspace all-target Clippy, rustfmt, deterministic sample generation, packaged asset equality, on-device demo sample navigation and XLSX checks, independent source and visual review
</commit_message>
<xml_diff>
--- a/demo/src/main/assets/samples/sample.pptx
+++ b/demo/src/main/assets/samples/sample.pptx
@@ -9,6 +9,7 @@
     <p:sldMasterId id="2147483652" r:id="rMaster4"/>
     <p:sldMasterId id="2147483653" r:id="rMaster5"/>
     <p:sldMasterId id="2147483654" r:id="rMaster6"/>
+    <p:sldMasterId id="2147483655" r:id="rMaster7"/>
   </p:sldMasterIdLst>
   <p:sldIdLst>
     <p:sldId id="256" r:id="rSlide0"/>
@@ -27,6 +28,8 @@
     <p:sldId id="269" r:id="rSlide13"/>
     <p:sldId id="270" r:id="rSlide14"/>
     <p:sldId id="271" r:id="rSlide15"/>
+    <p:sldId id="272" r:id="rSlide16"/>
+    <p:sldId id="273" r:id="rSlide17"/>
   </p:sldIdLst>
   <p:sldSz cx="12192000" cy="6858000" type="screen16x9"/>
   <p:notesSz cx="6858000" cy="9144000"/>
@@ -4427,6 +4430,2153 @@
 </a:theme>
 </file>
 
+<file path=ppt/showcase/compatibility/slideLayouts/slideLayout1.xml><?xml version="1.0" encoding="utf-8"?>
+<p:sldLayout xmlns:p="http://schemas.openxmlformats.org/presentationml/2006/main" xmlns:a="http://schemas.openxmlformats.org/drawingml/2006/main" type="blank" preserve="1">
+  <p:cSld name="Blank">
+    <p:spTree>
+      <p:nvGrpSpPr>
+        <p:cNvPr id="2" name="Showcase canvas"/>
+        <p:cNvGrpSpPr/>
+        <p:nvPr/>
+      </p:nvGrpSpPr>
+      <p:grpSpPr/>
+      <p:grpSp>
+        <p:nvGrpSpPr>
+          <p:cNvPr id="3" name="Source slide, centered"/>
+          <p:cNvGrpSpPr/>
+          <p:nvPr/>
+        </p:nvGrpSpPr>
+        <p:grpSpPr>
+          <a:xfrm>
+            <a:off x="0" y="0"/>
+            <a:ext cx="12192000" cy="6858000"/>
+            <a:chOff x="0" y="0"/>
+            <a:chExt cx="12192000" cy="6858000"/>
+          </a:xfrm>
+        </p:grpSpPr>
+      </p:grpSp>
+    </p:spTree>
+  </p:cSld>
+  <p:clrMapOvr>
+    <a:masterClrMapping/>
+  </p:clrMapOvr>
+</p:sldLayout>
+</file>
+
+<file path=ppt/showcase/compatibility/slideMasters/slideMaster1.xml><?xml version="1.0" encoding="utf-8"?>
+<p:sldMaster xmlns:p="http://schemas.openxmlformats.org/presentationml/2006/main" xmlns:a="http://schemas.openxmlformats.org/drawingml/2006/main" xmlns:r="http://schemas.openxmlformats.org/officeDocument/2006/relationships">
+  <p:cSld name="Fixture master">
+    <p:spTree>
+      <p:nvGrpSpPr>
+        <p:cNvPr id="2" name="Showcase canvas"/>
+        <p:cNvGrpSpPr/>
+        <p:nvPr/>
+      </p:nvGrpSpPr>
+      <p:grpSpPr/>
+      <p:grpSp>
+        <p:nvGrpSpPr>
+          <p:cNvPr id="3" name="Source slide, centered"/>
+          <p:cNvGrpSpPr/>
+          <p:nvPr/>
+        </p:nvGrpSpPr>
+        <p:grpSpPr>
+          <a:xfrm>
+            <a:off x="0" y="0"/>
+            <a:ext cx="12192000" cy="6858000"/>
+            <a:chOff x="0" y="0"/>
+            <a:chExt cx="12192000" cy="6858000"/>
+          </a:xfrm>
+        </p:grpSpPr>
+      </p:grpSp>
+    </p:spTree>
+  </p:cSld>
+  <p:clrMap accent1="accent1" accent2="accent2" accent3="accent3" accent4="accent4" accent5="accent5" accent6="accent6" bg1="lt1" bg2="lt2" tx1="dk1" tx2="dk2" hlink="hlink" folHlink="folHlink"/>
+  <p:sldLayoutIdLst>
+    <p:sldLayoutId id="2147483655" r:id="rLayout"/>
+  </p:sldLayoutIdLst>
+  <p:txStyles>
+    <p:titleStyle/>
+    <p:bodyStyle/>
+    <p:otherStyle>
+      <a:lvl1pPr>
+        <a:defRPr sz="1800">
+          <a:solidFill>
+            <a:srgbClr val="202124"/>
+          </a:solidFill>
+        </a:defRPr>
+      </a:lvl1pPr>
+    </p:otherStyle>
+  </p:txStyles>
+</p:sldMaster>
+</file>
+
+<file path=ppt/showcase/compatibility/slides/slide1.xml><?xml version="1.0" encoding="utf-8"?>
+<p:sld xmlns:p="http://schemas.openxmlformats.org/presentationml/2006/main" xmlns:a="http://schemas.openxmlformats.org/drawingml/2006/main">
+  <p:cSld>
+    <p:bg>
+      <p:bgPr>
+        <a:solidFill>
+          <a:srgbClr val="102238"/>
+        </a:solidFill>
+      </p:bgPr>
+    </p:bg>
+    <p:spTree>
+      <p:nvGrpSpPr>
+        <p:cNvPr id="28" name="Showcase canvas"/>
+        <p:cNvGrpSpPr/>
+        <p:nvPr/>
+      </p:nvGrpSpPr>
+      <p:grpSpPr/>
+      <p:grpSp>
+        <p:nvGrpSpPr>
+          <p:cNvPr id="29" name="Source slide, centered"/>
+          <p:cNvGrpSpPr/>
+          <p:nvPr/>
+        </p:nvGrpSpPr>
+        <p:grpSpPr>
+          <a:xfrm>
+            <a:off x="0" y="0"/>
+            <a:ext cx="12192000" cy="6858000"/>
+            <a:chOff x="0" y="0"/>
+            <a:chExt cx="12192000" cy="6858000"/>
+          </a:xfrm>
+        </p:grpSpPr>
+        <p:sp>
+          <p:nvSpPr>
+            <p:cNvPr id="2" name="Compatibility explanation"/>
+            <p:cNvSpPr txBox="1"/>
+            <p:nvPr/>
+          </p:nvSpPr>
+          <p:spPr>
+            <a:xfrm>
+              <a:off x="508000" y="355600"/>
+              <a:ext cx="11176000" cy="609600"/>
+            </a:xfrm>
+            <a:noFill/>
+          </p:spPr>
+          <p:txBody>
+            <a:bodyPr wrap="none" lIns="0" rIns="0" tIns="0" bIns="0"/>
+            <a:lstStyle/>
+            <a:p>
+              <a:r>
+                <a:rPr sz="3200">
+                  <a:solidFill>
+                    <a:srgbClr val="DCE7F3"/>
+                  </a:solidFill>
+                </a:rPr>
+                <a:t>预设图形 · 三角形与菱形</a:t>
+              </a:r>
+            </a:p>
+          </p:txBody>
+        </p:sp>
+        <p:sp>
+          <p:nvSpPr>
+            <p:cNvPr id="3" name="Compatibility explanation"/>
+            <p:cNvSpPr txBox="1"/>
+            <p:nvPr/>
+          </p:nvSpPr>
+          <p:spPr>
+            <a:xfrm>
+              <a:off x="508000" y="1092200"/>
+              <a:ext cx="11176000" cy="330200"/>
+            </a:xfrm>
+            <a:noFill/>
+          </p:spPr>
+          <p:txBody>
+            <a:bodyPr wrap="none" lIns="0" rIns="0" tIns="0" bIns="0"/>
+            <a:lstStyle/>
+            <a:p>
+              <a:r>
+                <a:rPr sz="1700">
+                  <a:solidFill>
+                    <a:srgbClr val="DCE7F3"/>
+                  </a:solidFill>
+                </a:rPr>
+                <a:t>上排为默认轮廓，下排为顶点调整、水平翻转和旋转。填色与描边应保持完整。</a:t>
+              </a:r>
+            </a:p>
+          </p:txBody>
+        </p:sp>
+        <p:sp>
+          <p:nvSpPr>
+            <p:cNvPr id="10" name="Compatibility explanation"/>
+            <p:cNvSpPr txBox="1"/>
+            <p:nvPr/>
+          </p:nvSpPr>
+          <p:spPr>
+            <a:xfrm>
+              <a:off x="508000" y="1600200"/>
+              <a:ext cx="3606800" cy="330200"/>
+            </a:xfrm>
+            <a:noFill/>
+          </p:spPr>
+          <p:txBody>
+            <a:bodyPr wrap="none" lIns="0" rIns="0" tIns="0" bIns="0"/>
+            <a:lstStyle/>
+            <a:p>
+              <a:r>
+                <a:rPr sz="1800">
+                  <a:solidFill>
+                    <a:srgbClr val="DCE7F3"/>
+                  </a:solidFill>
+                </a:rPr>
+                <a:t>三角形</a:t>
+              </a:r>
+            </a:p>
+          </p:txBody>
+        </p:sp>
+        <p:sp>
+          <p:nvSpPr>
+            <p:cNvPr id="11" name="三角形"/>
+            <p:cNvSpPr/>
+            <p:nvPr/>
+          </p:nvSpPr>
+          <p:spPr>
+            <a:xfrm>
+              <a:off x="1422400" y="2133600"/>
+              <a:ext cx="1625600" cy="1270000"/>
+            </a:xfrm>
+            <a:prstGeom prst="triangle">
+              <a:avLst/>
+            </a:prstGeom>
+            <a:solidFill>
+              <a:srgbClr val="45CFC0"/>
+            </a:solidFill>
+            <a:ln w="25400">
+              <a:solidFill>
+                <a:srgbClr val="FFFFFF"/>
+              </a:solidFill>
+            </a:ln>
+          </p:spPr>
+        </p:sp>
+        <p:sp>
+          <p:nvSpPr>
+            <p:cNvPr id="12" name="Compatibility explanation"/>
+            <p:cNvSpPr txBox="1"/>
+            <p:nvPr/>
+          </p:nvSpPr>
+          <p:spPr>
+            <a:xfrm>
+              <a:off x="508000" y="3505200"/>
+              <a:ext cx="3606800" cy="304800"/>
+            </a:xfrm>
+            <a:noFill/>
+          </p:spPr>
+          <p:txBody>
+            <a:bodyPr wrap="none" lIns="0" rIns="0" tIns="0" bIns="0"/>
+            <a:lstStyle/>
+            <a:p>
+              <a:r>
+                <a:rPr sz="1600">
+                  <a:solidFill>
+                    <a:srgbClr val="DCE7F3"/>
+                  </a:solidFill>
+                </a:rPr>
+                <a:t>顶点位于上边中点</a:t>
+              </a:r>
+            </a:p>
+          </p:txBody>
+        </p:sp>
+        <p:sp>
+          <p:nvSpPr>
+            <p:cNvPr id="13" name="Compatibility explanation"/>
+            <p:cNvSpPr txBox="1"/>
+            <p:nvPr/>
+          </p:nvSpPr>
+          <p:spPr>
+            <a:xfrm>
+              <a:off x="4292600" y="1600200"/>
+              <a:ext cx="3606800" cy="330200"/>
+            </a:xfrm>
+            <a:noFill/>
+          </p:spPr>
+          <p:txBody>
+            <a:bodyPr wrap="none" lIns="0" rIns="0" tIns="0" bIns="0"/>
+            <a:lstStyle/>
+            <a:p>
+              <a:r>
+                <a:rPr sz="1800">
+                  <a:solidFill>
+                    <a:srgbClr val="DCE7F3"/>
+                  </a:solidFill>
+                </a:rPr>
+                <a:t>直角三角形</a:t>
+              </a:r>
+            </a:p>
+          </p:txBody>
+        </p:sp>
+        <p:sp>
+          <p:nvSpPr>
+            <p:cNvPr id="14" name="直角三角形"/>
+            <p:cNvSpPr/>
+            <p:nvPr/>
+          </p:nvSpPr>
+          <p:spPr>
+            <a:xfrm>
+              <a:off x="5207000" y="2133600"/>
+              <a:ext cx="1625600" cy="1270000"/>
+            </a:xfrm>
+            <a:prstGeom prst="rtTriangle">
+              <a:avLst/>
+            </a:prstGeom>
+            <a:solidFill>
+              <a:srgbClr val="E9C46A"/>
+            </a:solidFill>
+            <a:ln w="25400">
+              <a:solidFill>
+                <a:srgbClr val="FFFFFF"/>
+              </a:solidFill>
+            </a:ln>
+          </p:spPr>
+        </p:sp>
+        <p:sp>
+          <p:nvSpPr>
+            <p:cNvPr id="15" name="Compatibility explanation"/>
+            <p:cNvSpPr txBox="1"/>
+            <p:nvPr/>
+          </p:nvSpPr>
+          <p:spPr>
+            <a:xfrm>
+              <a:off x="4292600" y="3505200"/>
+              <a:ext cx="3606800" cy="304800"/>
+            </a:xfrm>
+            <a:noFill/>
+          </p:spPr>
+          <p:txBody>
+            <a:bodyPr wrap="none" lIns="0" rIns="0" tIns="0" bIns="0"/>
+            <a:lstStyle/>
+            <a:p>
+              <a:r>
+                <a:rPr sz="1600">
+                  <a:solidFill>
+                    <a:srgbClr val="DCE7F3"/>
+                  </a:solidFill>
+                </a:rPr>
+                <a:t>直角位于左下方</a:t>
+              </a:r>
+            </a:p>
+          </p:txBody>
+        </p:sp>
+        <p:sp>
+          <p:nvSpPr>
+            <p:cNvPr id="16" name="Compatibility explanation"/>
+            <p:cNvSpPr txBox="1"/>
+            <p:nvPr/>
+          </p:nvSpPr>
+          <p:spPr>
+            <a:xfrm>
+              <a:off x="8077200" y="1600200"/>
+              <a:ext cx="3606800" cy="330200"/>
+            </a:xfrm>
+            <a:noFill/>
+          </p:spPr>
+          <p:txBody>
+            <a:bodyPr wrap="none" lIns="0" rIns="0" tIns="0" bIns="0"/>
+            <a:lstStyle/>
+            <a:p>
+              <a:r>
+                <a:rPr sz="1800">
+                  <a:solidFill>
+                    <a:srgbClr val="DCE7F3"/>
+                  </a:solidFill>
+                </a:rPr>
+                <a:t>菱形</a:t>
+              </a:r>
+            </a:p>
+          </p:txBody>
+        </p:sp>
+        <p:sp>
+          <p:nvSpPr>
+            <p:cNvPr id="17" name="菱形"/>
+            <p:cNvSpPr/>
+            <p:nvPr/>
+          </p:nvSpPr>
+          <p:spPr>
+            <a:xfrm>
+              <a:off x="8991600" y="2133600"/>
+              <a:ext cx="1625600" cy="1270000"/>
+            </a:xfrm>
+            <a:prstGeom prst="diamond">
+              <a:avLst/>
+            </a:prstGeom>
+            <a:solidFill>
+              <a:srgbClr val="8CB9ED"/>
+            </a:solidFill>
+            <a:ln w="25400">
+              <a:solidFill>
+                <a:srgbClr val="FFFFFF"/>
+              </a:solidFill>
+            </a:ln>
+          </p:spPr>
+        </p:sp>
+        <p:sp>
+          <p:nvSpPr>
+            <p:cNvPr id="18" name="Compatibility explanation"/>
+            <p:cNvSpPr txBox="1"/>
+            <p:nvPr/>
+          </p:nvSpPr>
+          <p:spPr>
+            <a:xfrm>
+              <a:off x="8077200" y="3505200"/>
+              <a:ext cx="3606800" cy="304800"/>
+            </a:xfrm>
+            <a:noFill/>
+          </p:spPr>
+          <p:txBody>
+            <a:bodyPr wrap="none" lIns="0" rIns="0" tIns="0" bIns="0"/>
+            <a:lstStyle/>
+            <a:p>
+              <a:r>
+                <a:rPr sz="1600">
+                  <a:solidFill>
+                    <a:srgbClr val="DCE7F3"/>
+                  </a:solidFill>
+                </a:rPr>
+                <a:t>四个顶点位于边中点</a:t>
+              </a:r>
+            </a:p>
+          </p:txBody>
+        </p:sp>
+        <p:sp>
+          <p:nvSpPr>
+            <p:cNvPr id="19" name="Compatibility explanation"/>
+            <p:cNvSpPr txBox="1"/>
+            <p:nvPr/>
+          </p:nvSpPr>
+          <p:spPr>
+            <a:xfrm>
+              <a:off x="508000" y="3962400"/>
+              <a:ext cx="3606800" cy="330200"/>
+            </a:xfrm>
+            <a:noFill/>
+          </p:spPr>
+          <p:txBody>
+            <a:bodyPr wrap="none" lIns="0" rIns="0" tIns="0" bIns="0"/>
+            <a:lstStyle/>
+            <a:p>
+              <a:r>
+                <a:rPr sz="1800">
+                  <a:solidFill>
+                    <a:srgbClr val="DCE7F3"/>
+                  </a:solidFill>
+                </a:rPr>
+                <a:t>三角形 · 顶点调整</a:t>
+              </a:r>
+            </a:p>
+          </p:txBody>
+        </p:sp>
+        <p:sp>
+          <p:nvSpPr>
+            <p:cNvPr id="20" name="三角形 · 顶点调整"/>
+            <p:cNvSpPr/>
+            <p:nvPr/>
+          </p:nvSpPr>
+          <p:spPr>
+            <a:xfrm>
+              <a:off x="1422400" y="4495800"/>
+              <a:ext cx="1625600" cy="1270000"/>
+            </a:xfrm>
+            <a:prstGeom prst="triangle">
+              <a:avLst>
+                <a:gd name="adj" fmla="val 25000"/>
+              </a:avLst>
+            </a:prstGeom>
+            <a:solidFill>
+              <a:srgbClr val="45CFC0"/>
+            </a:solidFill>
+            <a:ln w="25400">
+              <a:solidFill>
+                <a:srgbClr val="FFFFFF"/>
+              </a:solidFill>
+            </a:ln>
+          </p:spPr>
+        </p:sp>
+        <p:sp>
+          <p:nvSpPr>
+            <p:cNvPr id="21" name="Compatibility explanation"/>
+            <p:cNvSpPr txBox="1"/>
+            <p:nvPr/>
+          </p:nvSpPr>
+          <p:spPr>
+            <a:xfrm>
+              <a:off x="508000" y="6070600"/>
+              <a:ext cx="3606800" cy="304800"/>
+            </a:xfrm>
+            <a:noFill/>
+          </p:spPr>
+          <p:txBody>
+            <a:bodyPr wrap="none" lIns="0" rIns="0" tIns="0" bIns="0"/>
+            <a:lstStyle/>
+            <a:p>
+              <a:r>
+                <a:rPr sz="1600">
+                  <a:solidFill>
+                    <a:srgbClr val="DCE7F3"/>
+                  </a:solidFill>
+                </a:rPr>
+                <a:t>顶点位于宽度的 25% 处</a:t>
+              </a:r>
+            </a:p>
+          </p:txBody>
+        </p:sp>
+        <p:sp>
+          <p:nvSpPr>
+            <p:cNvPr id="22" name="Compatibility explanation"/>
+            <p:cNvSpPr txBox="1"/>
+            <p:nvPr/>
+          </p:nvSpPr>
+          <p:spPr>
+            <a:xfrm>
+              <a:off x="4292600" y="3962400"/>
+              <a:ext cx="3606800" cy="330200"/>
+            </a:xfrm>
+            <a:noFill/>
+          </p:spPr>
+          <p:txBody>
+            <a:bodyPr wrap="none" lIns="0" rIns="0" tIns="0" bIns="0"/>
+            <a:lstStyle/>
+            <a:p>
+              <a:r>
+                <a:rPr sz="1800">
+                  <a:solidFill>
+                    <a:srgbClr val="DCE7F3"/>
+                  </a:solidFill>
+                </a:rPr>
+                <a:t>直角三角形 · 水平翻转</a:t>
+              </a:r>
+            </a:p>
+          </p:txBody>
+        </p:sp>
+        <p:sp>
+          <p:nvSpPr>
+            <p:cNvPr id="23" name="直角三角形 · 水平翻转"/>
+            <p:cNvSpPr/>
+            <p:nvPr/>
+          </p:nvSpPr>
+          <p:spPr>
+            <a:xfrm flipH="1">
+              <a:off x="5207000" y="4495800"/>
+              <a:ext cx="1625600" cy="1270000"/>
+            </a:xfrm>
+            <a:prstGeom prst="rtTriangle">
+              <a:avLst/>
+            </a:prstGeom>
+            <a:solidFill>
+              <a:srgbClr val="E9C46A"/>
+            </a:solidFill>
+            <a:ln w="25400">
+              <a:solidFill>
+                <a:srgbClr val="FFFFFF"/>
+              </a:solidFill>
+            </a:ln>
+          </p:spPr>
+        </p:sp>
+        <p:sp>
+          <p:nvSpPr>
+            <p:cNvPr id="24" name="Compatibility explanation"/>
+            <p:cNvSpPr txBox="1"/>
+            <p:nvPr/>
+          </p:nvSpPr>
+          <p:spPr>
+            <a:xfrm>
+              <a:off x="4292600" y="6070600"/>
+              <a:ext cx="3606800" cy="304800"/>
+            </a:xfrm>
+            <a:noFill/>
+          </p:spPr>
+          <p:txBody>
+            <a:bodyPr wrap="none" lIns="0" rIns="0" tIns="0" bIns="0"/>
+            <a:lstStyle/>
+            <a:p>
+              <a:r>
+                <a:rPr sz="1600">
+                  <a:solidFill>
+                    <a:srgbClr val="DCE7F3"/>
+                  </a:solidFill>
+                </a:rPr>
+                <a:t>直角移至右下方</a:t>
+              </a:r>
+            </a:p>
+          </p:txBody>
+        </p:sp>
+        <p:sp>
+          <p:nvSpPr>
+            <p:cNvPr id="25" name="Compatibility explanation"/>
+            <p:cNvSpPr txBox="1"/>
+            <p:nvPr/>
+          </p:nvSpPr>
+          <p:spPr>
+            <a:xfrm>
+              <a:off x="8077200" y="3962400"/>
+              <a:ext cx="3606800" cy="330200"/>
+            </a:xfrm>
+            <a:noFill/>
+          </p:spPr>
+          <p:txBody>
+            <a:bodyPr wrap="none" lIns="0" rIns="0" tIns="0" bIns="0"/>
+            <a:lstStyle/>
+            <a:p>
+              <a:r>
+                <a:rPr sz="1800">
+                  <a:solidFill>
+                    <a:srgbClr val="DCE7F3"/>
+                  </a:solidFill>
+                </a:rPr>
+                <a:t>直角三角形 · 旋转 90°</a:t>
+              </a:r>
+            </a:p>
+          </p:txBody>
+        </p:sp>
+        <p:sp>
+          <p:nvSpPr>
+            <p:cNvPr id="26" name="直角三角形 · 旋转 90°"/>
+            <p:cNvSpPr/>
+            <p:nvPr/>
+          </p:nvSpPr>
+          <p:spPr>
+            <a:xfrm rot="5400000">
+              <a:off x="8991600" y="4495800"/>
+              <a:ext cx="1625600" cy="1270000"/>
+            </a:xfrm>
+            <a:prstGeom prst="rtTriangle">
+              <a:avLst/>
+            </a:prstGeom>
+            <a:solidFill>
+              <a:srgbClr val="8CB9ED"/>
+            </a:solidFill>
+            <a:ln w="25400">
+              <a:solidFill>
+                <a:srgbClr val="FFFFFF"/>
+              </a:solidFill>
+            </a:ln>
+          </p:spPr>
+        </p:sp>
+        <p:sp>
+          <p:nvSpPr>
+            <p:cNvPr id="27" name="Compatibility explanation"/>
+            <p:cNvSpPr txBox="1"/>
+            <p:nvPr/>
+          </p:nvSpPr>
+          <p:spPr>
+            <a:xfrm>
+              <a:off x="8077200" y="6070600"/>
+              <a:ext cx="3606800" cy="304800"/>
+            </a:xfrm>
+            <a:noFill/>
+          </p:spPr>
+          <p:txBody>
+            <a:bodyPr wrap="none" lIns="0" rIns="0" tIns="0" bIns="0"/>
+            <a:lstStyle/>
+            <a:p>
+              <a:r>
+                <a:rPr sz="1600">
+                  <a:solidFill>
+                    <a:srgbClr val="DCE7F3"/>
+                  </a:solidFill>
+                </a:rPr>
+                <a:t>顺时针旋转，直角移至左上方</a:t>
+              </a:r>
+            </a:p>
+          </p:txBody>
+        </p:sp>
+      </p:grpSp>
+    </p:spTree>
+  </p:cSld>
+</p:sld>
+</file>
+
+<file path=ppt/showcase/compatibility/slides/slide2.xml><?xml version="1.0" encoding="utf-8"?>
+<p:sld xmlns:p="http://schemas.openxmlformats.org/presentationml/2006/main" xmlns:a="http://schemas.openxmlformats.org/drawingml/2006/main">
+  <p:cSld>
+    <p:bg>
+      <p:bgPr>
+        <a:solidFill>
+          <a:srgbClr val="F4F7FA"/>
+        </a:solidFill>
+      </p:bgPr>
+    </p:bg>
+    <p:spTree>
+      <p:nvGrpSpPr>
+        <p:cNvPr id="42" name="Showcase canvas"/>
+        <p:cNvGrpSpPr/>
+        <p:nvPr/>
+      </p:nvGrpSpPr>
+      <p:grpSpPr/>
+      <p:grpSp>
+        <p:nvGrpSpPr>
+          <p:cNvPr id="43" name="Source slide, centered"/>
+          <p:cNvGrpSpPr/>
+          <p:nvPr/>
+        </p:nvGrpSpPr>
+        <p:grpSpPr>
+          <a:xfrm>
+            <a:off x="0" y="0"/>
+            <a:ext cx="12192000" cy="6858000"/>
+            <a:chOff x="0" y="0"/>
+            <a:chExt cx="12192000" cy="6858000"/>
+          </a:xfrm>
+        </p:grpSpPr>
+        <p:sp>
+          <p:nvSpPr>
+            <p:cNvPr id="2" name="Compatibility explanation"/>
+            <p:cNvSpPr txBox="1"/>
+            <p:nvPr/>
+          </p:nvSpPr>
+          <p:spPr>
+            <a:xfrm>
+              <a:off x="508000" y="355600"/>
+              <a:ext cx="11176000" cy="609600"/>
+            </a:xfrm>
+            <a:noFill/>
+          </p:spPr>
+          <p:txBody>
+            <a:bodyPr wrap="none" lIns="0" rIns="0" tIns="0" bIns="0"/>
+            <a:lstStyle/>
+            <a:p>
+              <a:r>
+                <a:rPr sz="3200">
+                  <a:solidFill>
+                    <a:srgbClr val="102238"/>
+                  </a:solidFill>
+                </a:rPr>
+                <a:t>自动编号 · 16 种常见格式</a:t>
+              </a:r>
+            </a:p>
+          </p:txBody>
+        </p:sp>
+        <p:sp>
+          <p:nvSpPr>
+            <p:cNvPr id="3" name="Compatibility explanation"/>
+            <p:cNvSpPr txBox="1"/>
+            <p:nvPr/>
+          </p:nvSpPr>
+          <p:spPr>
+            <a:xfrm>
+              <a:off x="508000" y="1092200"/>
+              <a:ext cx="11176000" cy="330200"/>
+            </a:xfrm>
+            <a:noFill/>
+          </p:spPr>
+          <p:txBody>
+            <a:bodyPr wrap="none" lIns="0" rIns="0" tIns="0" bIns="0"/>
+            <a:lstStyle/>
+            <a:p>
+              <a:r>
+                <a:rPr sz="1700">
+                  <a:solidFill>
+                    <a:srgbClr val="102238"/>
+                  </a:solidFill>
+                </a:rPr>
+                <a:t>每组从第 4 项开始，下一项应自动递增为 5。核对数字、字母、罗马数字及括号。</a:t>
+              </a:r>
+            </a:p>
+          </p:txBody>
+        </p:sp>
+        <p:sp>
+          <p:nvSpPr>
+            <p:cNvPr id="10" name="Compatibility explanation"/>
+            <p:cNvSpPr txBox="1"/>
+            <p:nvPr/>
+          </p:nvSpPr>
+          <p:spPr>
+            <a:xfrm>
+              <a:off x="508000" y="1600200"/>
+              <a:ext cx="2641600" cy="304800"/>
+            </a:xfrm>
+            <a:noFill/>
+          </p:spPr>
+          <p:txBody>
+            <a:bodyPr wrap="none" lIns="0" rIns="0" tIns="0" bIns="0"/>
+            <a:lstStyle/>
+            <a:p>
+              <a:r>
+                <a:rPr sz="1600">
+                  <a:solidFill>
+                    <a:srgbClr val="24745C"/>
+                  </a:solidFill>
+                </a:rPr>
+                <a:t>数字 · 句点</a:t>
+              </a:r>
+            </a:p>
+          </p:txBody>
+        </p:sp>
+        <p:sp>
+          <p:nvSpPr>
+            <p:cNvPr id="11" name="Compatibility explanation"/>
+            <p:cNvSpPr txBox="1"/>
+            <p:nvPr/>
+          </p:nvSpPr>
+          <p:spPr>
+            <a:xfrm>
+              <a:off x="508000" y="1930400"/>
+              <a:ext cx="2641600" cy="685800"/>
+            </a:xfrm>
+            <a:noFill/>
+          </p:spPr>
+          <p:txBody>
+            <a:bodyPr wrap="none" lIns="0" rIns="0" tIns="0" bIns="0"/>
+            <a:lstStyle/>
+            <a:p>
+              <a:pPr>
+                <a:lnSpc>
+                  <a:spcPts val="2300"/>
+                </a:lnSpc>
+                <a:buAutoNum type="arabicPeriod" startAt="4"/>
+              </a:pPr>
+              <a:r>
+                <a:rPr sz="1800">
+                  <a:solidFill>
+                    <a:srgbClr val="102238"/>
+                  </a:solidFill>
+                </a:rPr>
+                <a:t>步骤一</a:t>
+              </a:r>
+            </a:p>
+            <a:p>
+              <a:pPr>
+                <a:lnSpc>
+                  <a:spcPts val="2300"/>
+                </a:lnSpc>
+                <a:buAutoNum type="arabicPeriod"/>
+              </a:pPr>
+              <a:r>
+                <a:rPr sz="1800">
+                  <a:solidFill>
+                    <a:srgbClr val="102238"/>
+                  </a:solidFill>
+                </a:rPr>
+                <a:t>步骤二</a:t>
+              </a:r>
+            </a:p>
+          </p:txBody>
+        </p:sp>
+        <p:sp>
+          <p:nvSpPr>
+            <p:cNvPr id="12" name="Compatibility explanation"/>
+            <p:cNvSpPr txBox="1"/>
+            <p:nvPr/>
+          </p:nvSpPr>
+          <p:spPr>
+            <a:xfrm>
+              <a:off x="3352800" y="1600200"/>
+              <a:ext cx="2641600" cy="304800"/>
+            </a:xfrm>
+            <a:noFill/>
+          </p:spPr>
+          <p:txBody>
+            <a:bodyPr wrap="none" lIns="0" rIns="0" tIns="0" bIns="0"/>
+            <a:lstStyle/>
+            <a:p>
+              <a:r>
+                <a:rPr sz="1600">
+                  <a:solidFill>
+                    <a:srgbClr val="24745C"/>
+                  </a:solidFill>
+                </a:rPr>
+                <a:t>数字 · 右括号</a:t>
+              </a:r>
+            </a:p>
+          </p:txBody>
+        </p:sp>
+        <p:sp>
+          <p:nvSpPr>
+            <p:cNvPr id="13" name="Compatibility explanation"/>
+            <p:cNvSpPr txBox="1"/>
+            <p:nvPr/>
+          </p:nvSpPr>
+          <p:spPr>
+            <a:xfrm>
+              <a:off x="3352800" y="1930400"/>
+              <a:ext cx="2641600" cy="685800"/>
+            </a:xfrm>
+            <a:noFill/>
+          </p:spPr>
+          <p:txBody>
+            <a:bodyPr wrap="none" lIns="0" rIns="0" tIns="0" bIns="0"/>
+            <a:lstStyle/>
+            <a:p>
+              <a:pPr>
+                <a:lnSpc>
+                  <a:spcPts val="2300"/>
+                </a:lnSpc>
+                <a:buAutoNum type="arabicParenR" startAt="4"/>
+              </a:pPr>
+              <a:r>
+                <a:rPr sz="1800">
+                  <a:solidFill>
+                    <a:srgbClr val="102238"/>
+                  </a:solidFill>
+                </a:rPr>
+                <a:t>步骤一</a:t>
+              </a:r>
+            </a:p>
+            <a:p>
+              <a:pPr>
+                <a:lnSpc>
+                  <a:spcPts val="2300"/>
+                </a:lnSpc>
+                <a:buAutoNum type="arabicParenR"/>
+              </a:pPr>
+              <a:r>
+                <a:rPr sz="1800">
+                  <a:solidFill>
+                    <a:srgbClr val="102238"/>
+                  </a:solidFill>
+                </a:rPr>
+                <a:t>步骤二</a:t>
+              </a:r>
+            </a:p>
+          </p:txBody>
+        </p:sp>
+        <p:sp>
+          <p:nvSpPr>
+            <p:cNvPr id="14" name="Compatibility explanation"/>
+            <p:cNvSpPr txBox="1"/>
+            <p:nvPr/>
+          </p:nvSpPr>
+          <p:spPr>
+            <a:xfrm>
+              <a:off x="6197600" y="1600200"/>
+              <a:ext cx="2641600" cy="304800"/>
+            </a:xfrm>
+            <a:noFill/>
+          </p:spPr>
+          <p:txBody>
+            <a:bodyPr wrap="none" lIns="0" rIns="0" tIns="0" bIns="0"/>
+            <a:lstStyle/>
+            <a:p>
+              <a:r>
+                <a:rPr sz="1600">
+                  <a:solidFill>
+                    <a:srgbClr val="24745C"/>
+                  </a:solidFill>
+                </a:rPr>
+                <a:t>数字 · 双括号</a:t>
+              </a:r>
+            </a:p>
+          </p:txBody>
+        </p:sp>
+        <p:sp>
+          <p:nvSpPr>
+            <p:cNvPr id="15" name="Compatibility explanation"/>
+            <p:cNvSpPr txBox="1"/>
+            <p:nvPr/>
+          </p:nvSpPr>
+          <p:spPr>
+            <a:xfrm>
+              <a:off x="6197600" y="1930400"/>
+              <a:ext cx="2641600" cy="685800"/>
+            </a:xfrm>
+            <a:noFill/>
+          </p:spPr>
+          <p:txBody>
+            <a:bodyPr wrap="none" lIns="0" rIns="0" tIns="0" bIns="0"/>
+            <a:lstStyle/>
+            <a:p>
+              <a:pPr>
+                <a:lnSpc>
+                  <a:spcPts val="2300"/>
+                </a:lnSpc>
+                <a:buAutoNum type="arabicParenBoth" startAt="4"/>
+              </a:pPr>
+              <a:r>
+                <a:rPr sz="1800">
+                  <a:solidFill>
+                    <a:srgbClr val="102238"/>
+                  </a:solidFill>
+                </a:rPr>
+                <a:t>步骤一</a:t>
+              </a:r>
+            </a:p>
+            <a:p>
+              <a:pPr>
+                <a:lnSpc>
+                  <a:spcPts val="2300"/>
+                </a:lnSpc>
+                <a:buAutoNum type="arabicParenBoth"/>
+              </a:pPr>
+              <a:r>
+                <a:rPr sz="1800">
+                  <a:solidFill>
+                    <a:srgbClr val="102238"/>
+                  </a:solidFill>
+                </a:rPr>
+                <a:t>步骤二</a:t>
+              </a:r>
+            </a:p>
+          </p:txBody>
+        </p:sp>
+        <p:sp>
+          <p:nvSpPr>
+            <p:cNvPr id="16" name="Compatibility explanation"/>
+            <p:cNvSpPr txBox="1"/>
+            <p:nvPr/>
+          </p:nvSpPr>
+          <p:spPr>
+            <a:xfrm>
+              <a:off x="9042400" y="1600200"/>
+              <a:ext cx="2641600" cy="304800"/>
+            </a:xfrm>
+            <a:noFill/>
+          </p:spPr>
+          <p:txBody>
+            <a:bodyPr wrap="none" lIns="0" rIns="0" tIns="0" bIns="0"/>
+            <a:lstStyle/>
+            <a:p>
+              <a:r>
+                <a:rPr sz="1600">
+                  <a:solidFill>
+                    <a:srgbClr val="24745C"/>
+                  </a:solidFill>
+                </a:rPr>
+                <a:t>数字 · 无标点</a:t>
+              </a:r>
+            </a:p>
+          </p:txBody>
+        </p:sp>
+        <p:sp>
+          <p:nvSpPr>
+            <p:cNvPr id="17" name="Compatibility explanation"/>
+            <p:cNvSpPr txBox="1"/>
+            <p:nvPr/>
+          </p:nvSpPr>
+          <p:spPr>
+            <a:xfrm>
+              <a:off x="9042400" y="1930400"/>
+              <a:ext cx="2641600" cy="685800"/>
+            </a:xfrm>
+            <a:noFill/>
+          </p:spPr>
+          <p:txBody>
+            <a:bodyPr wrap="none" lIns="0" rIns="0" tIns="0" bIns="0"/>
+            <a:lstStyle/>
+            <a:p>
+              <a:pPr>
+                <a:lnSpc>
+                  <a:spcPts val="2300"/>
+                </a:lnSpc>
+                <a:buAutoNum type="arabicPlain" startAt="4"/>
+              </a:pPr>
+              <a:r>
+                <a:rPr sz="1800">
+                  <a:solidFill>
+                    <a:srgbClr val="102238"/>
+                  </a:solidFill>
+                </a:rPr>
+                <a:t>步骤一</a:t>
+              </a:r>
+            </a:p>
+            <a:p>
+              <a:pPr>
+                <a:lnSpc>
+                  <a:spcPts val="2300"/>
+                </a:lnSpc>
+                <a:buAutoNum type="arabicPlain"/>
+              </a:pPr>
+              <a:r>
+                <a:rPr sz="1800">
+                  <a:solidFill>
+                    <a:srgbClr val="102238"/>
+                  </a:solidFill>
+                </a:rPr>
+                <a:t>步骤二</a:t>
+              </a:r>
+            </a:p>
+          </p:txBody>
+        </p:sp>
+        <p:sp>
+          <p:nvSpPr>
+            <p:cNvPr id="18" name="Compatibility explanation"/>
+            <p:cNvSpPr txBox="1"/>
+            <p:nvPr/>
+          </p:nvSpPr>
+          <p:spPr>
+            <a:xfrm>
+              <a:off x="508000" y="2743200"/>
+              <a:ext cx="2641600" cy="304800"/>
+            </a:xfrm>
+            <a:noFill/>
+          </p:spPr>
+          <p:txBody>
+            <a:bodyPr wrap="none" lIns="0" rIns="0" tIns="0" bIns="0"/>
+            <a:lstStyle/>
+            <a:p>
+              <a:r>
+                <a:rPr sz="1600">
+                  <a:solidFill>
+                    <a:srgbClr val="24745C"/>
+                  </a:solidFill>
+                </a:rPr>
+                <a:t>小写字母 · 句点</a:t>
+              </a:r>
+            </a:p>
+          </p:txBody>
+        </p:sp>
+        <p:sp>
+          <p:nvSpPr>
+            <p:cNvPr id="19" name="Compatibility explanation"/>
+            <p:cNvSpPr txBox="1"/>
+            <p:nvPr/>
+          </p:nvSpPr>
+          <p:spPr>
+            <a:xfrm>
+              <a:off x="508000" y="3073400"/>
+              <a:ext cx="2641600" cy="685800"/>
+            </a:xfrm>
+            <a:noFill/>
+          </p:spPr>
+          <p:txBody>
+            <a:bodyPr wrap="none" lIns="0" rIns="0" tIns="0" bIns="0"/>
+            <a:lstStyle/>
+            <a:p>
+              <a:pPr>
+                <a:lnSpc>
+                  <a:spcPts val="2300"/>
+                </a:lnSpc>
+                <a:buAutoNum type="alphaLcPeriod" startAt="4"/>
+              </a:pPr>
+              <a:r>
+                <a:rPr sz="1800">
+                  <a:solidFill>
+                    <a:srgbClr val="102238"/>
+                  </a:solidFill>
+                </a:rPr>
+                <a:t>步骤一</a:t>
+              </a:r>
+            </a:p>
+            <a:p>
+              <a:pPr>
+                <a:lnSpc>
+                  <a:spcPts val="2300"/>
+                </a:lnSpc>
+                <a:buAutoNum type="alphaLcPeriod"/>
+              </a:pPr>
+              <a:r>
+                <a:rPr sz="1800">
+                  <a:solidFill>
+                    <a:srgbClr val="102238"/>
+                  </a:solidFill>
+                </a:rPr>
+                <a:t>步骤二</a:t>
+              </a:r>
+            </a:p>
+          </p:txBody>
+        </p:sp>
+        <p:sp>
+          <p:nvSpPr>
+            <p:cNvPr id="20" name="Compatibility explanation"/>
+            <p:cNvSpPr txBox="1"/>
+            <p:nvPr/>
+          </p:nvSpPr>
+          <p:spPr>
+            <a:xfrm>
+              <a:off x="3352800" y="2743200"/>
+              <a:ext cx="2641600" cy="304800"/>
+            </a:xfrm>
+            <a:noFill/>
+          </p:spPr>
+          <p:txBody>
+            <a:bodyPr wrap="none" lIns="0" rIns="0" tIns="0" bIns="0"/>
+            <a:lstStyle/>
+            <a:p>
+              <a:r>
+                <a:rPr sz="1600">
+                  <a:solidFill>
+                    <a:srgbClr val="24745C"/>
+                  </a:solidFill>
+                </a:rPr>
+                <a:t>小写字母 · 右括号</a:t>
+              </a:r>
+            </a:p>
+          </p:txBody>
+        </p:sp>
+        <p:sp>
+          <p:nvSpPr>
+            <p:cNvPr id="21" name="Compatibility explanation"/>
+            <p:cNvSpPr txBox="1"/>
+            <p:nvPr/>
+          </p:nvSpPr>
+          <p:spPr>
+            <a:xfrm>
+              <a:off x="3352800" y="3073400"/>
+              <a:ext cx="2641600" cy="685800"/>
+            </a:xfrm>
+            <a:noFill/>
+          </p:spPr>
+          <p:txBody>
+            <a:bodyPr wrap="none" lIns="0" rIns="0" tIns="0" bIns="0"/>
+            <a:lstStyle/>
+            <a:p>
+              <a:pPr>
+                <a:lnSpc>
+                  <a:spcPts val="2300"/>
+                </a:lnSpc>
+                <a:buAutoNum type="alphaLcParenR" startAt="4"/>
+              </a:pPr>
+              <a:r>
+                <a:rPr sz="1800">
+                  <a:solidFill>
+                    <a:srgbClr val="102238"/>
+                  </a:solidFill>
+                </a:rPr>
+                <a:t>步骤一</a:t>
+              </a:r>
+            </a:p>
+            <a:p>
+              <a:pPr>
+                <a:lnSpc>
+                  <a:spcPts val="2300"/>
+                </a:lnSpc>
+                <a:buAutoNum type="alphaLcParenR"/>
+              </a:pPr>
+              <a:r>
+                <a:rPr sz="1800">
+                  <a:solidFill>
+                    <a:srgbClr val="102238"/>
+                  </a:solidFill>
+                </a:rPr>
+                <a:t>步骤二</a:t>
+              </a:r>
+            </a:p>
+          </p:txBody>
+        </p:sp>
+        <p:sp>
+          <p:nvSpPr>
+            <p:cNvPr id="22" name="Compatibility explanation"/>
+            <p:cNvSpPr txBox="1"/>
+            <p:nvPr/>
+          </p:nvSpPr>
+          <p:spPr>
+            <a:xfrm>
+              <a:off x="6197600" y="2743200"/>
+              <a:ext cx="2641600" cy="304800"/>
+            </a:xfrm>
+            <a:noFill/>
+          </p:spPr>
+          <p:txBody>
+            <a:bodyPr wrap="none" lIns="0" rIns="0" tIns="0" bIns="0"/>
+            <a:lstStyle/>
+            <a:p>
+              <a:r>
+                <a:rPr sz="1600">
+                  <a:solidFill>
+                    <a:srgbClr val="24745C"/>
+                  </a:solidFill>
+                </a:rPr>
+                <a:t>小写字母 · 双括号</a:t>
+              </a:r>
+            </a:p>
+          </p:txBody>
+        </p:sp>
+        <p:sp>
+          <p:nvSpPr>
+            <p:cNvPr id="23" name="Compatibility explanation"/>
+            <p:cNvSpPr txBox="1"/>
+            <p:nvPr/>
+          </p:nvSpPr>
+          <p:spPr>
+            <a:xfrm>
+              <a:off x="6197600" y="3073400"/>
+              <a:ext cx="2641600" cy="685800"/>
+            </a:xfrm>
+            <a:noFill/>
+          </p:spPr>
+          <p:txBody>
+            <a:bodyPr wrap="none" lIns="0" rIns="0" tIns="0" bIns="0"/>
+            <a:lstStyle/>
+            <a:p>
+              <a:pPr>
+                <a:lnSpc>
+                  <a:spcPts val="2300"/>
+                </a:lnSpc>
+                <a:buAutoNum type="alphaLcParenBoth" startAt="4"/>
+              </a:pPr>
+              <a:r>
+                <a:rPr sz="1800">
+                  <a:solidFill>
+                    <a:srgbClr val="102238"/>
+                  </a:solidFill>
+                </a:rPr>
+                <a:t>步骤一</a:t>
+              </a:r>
+            </a:p>
+            <a:p>
+              <a:pPr>
+                <a:lnSpc>
+                  <a:spcPts val="2300"/>
+                </a:lnSpc>
+                <a:buAutoNum type="alphaLcParenBoth"/>
+              </a:pPr>
+              <a:r>
+                <a:rPr sz="1800">
+                  <a:solidFill>
+                    <a:srgbClr val="102238"/>
+                  </a:solidFill>
+                </a:rPr>
+                <a:t>步骤二</a:t>
+              </a:r>
+            </a:p>
+          </p:txBody>
+        </p:sp>
+        <p:sp>
+          <p:nvSpPr>
+            <p:cNvPr id="24" name="Compatibility explanation"/>
+            <p:cNvSpPr txBox="1"/>
+            <p:nvPr/>
+          </p:nvSpPr>
+          <p:spPr>
+            <a:xfrm>
+              <a:off x="9042400" y="2743200"/>
+              <a:ext cx="2641600" cy="304800"/>
+            </a:xfrm>
+            <a:noFill/>
+          </p:spPr>
+          <p:txBody>
+            <a:bodyPr wrap="none" lIns="0" rIns="0" tIns="0" bIns="0"/>
+            <a:lstStyle/>
+            <a:p>
+              <a:r>
+                <a:rPr sz="1600">
+                  <a:solidFill>
+                    <a:srgbClr val="24745C"/>
+                  </a:solidFill>
+                </a:rPr>
+                <a:t>大写字母 · 句点</a:t>
+              </a:r>
+            </a:p>
+          </p:txBody>
+        </p:sp>
+        <p:sp>
+          <p:nvSpPr>
+            <p:cNvPr id="25" name="Compatibility explanation"/>
+            <p:cNvSpPr txBox="1"/>
+            <p:nvPr/>
+          </p:nvSpPr>
+          <p:spPr>
+            <a:xfrm>
+              <a:off x="9042400" y="3073400"/>
+              <a:ext cx="2641600" cy="685800"/>
+            </a:xfrm>
+            <a:noFill/>
+          </p:spPr>
+          <p:txBody>
+            <a:bodyPr wrap="none" lIns="0" rIns="0" tIns="0" bIns="0"/>
+            <a:lstStyle/>
+            <a:p>
+              <a:pPr>
+                <a:lnSpc>
+                  <a:spcPts val="2300"/>
+                </a:lnSpc>
+                <a:buAutoNum type="alphaUcPeriod" startAt="4"/>
+              </a:pPr>
+              <a:r>
+                <a:rPr sz="1800">
+                  <a:solidFill>
+                    <a:srgbClr val="102238"/>
+                  </a:solidFill>
+                </a:rPr>
+                <a:t>步骤一</a:t>
+              </a:r>
+            </a:p>
+            <a:p>
+              <a:pPr>
+                <a:lnSpc>
+                  <a:spcPts val="2300"/>
+                </a:lnSpc>
+                <a:buAutoNum type="alphaUcPeriod"/>
+              </a:pPr>
+              <a:r>
+                <a:rPr sz="1800">
+                  <a:solidFill>
+                    <a:srgbClr val="102238"/>
+                  </a:solidFill>
+                </a:rPr>
+                <a:t>步骤二</a:t>
+              </a:r>
+            </a:p>
+          </p:txBody>
+        </p:sp>
+        <p:sp>
+          <p:nvSpPr>
+            <p:cNvPr id="26" name="Compatibility explanation"/>
+            <p:cNvSpPr txBox="1"/>
+            <p:nvPr/>
+          </p:nvSpPr>
+          <p:spPr>
+            <a:xfrm>
+              <a:off x="508000" y="3886200"/>
+              <a:ext cx="2641600" cy="304800"/>
+            </a:xfrm>
+            <a:noFill/>
+          </p:spPr>
+          <p:txBody>
+            <a:bodyPr wrap="none" lIns="0" rIns="0" tIns="0" bIns="0"/>
+            <a:lstStyle/>
+            <a:p>
+              <a:r>
+                <a:rPr sz="1600">
+                  <a:solidFill>
+                    <a:srgbClr val="24745C"/>
+                  </a:solidFill>
+                </a:rPr>
+                <a:t>大写字母 · 右括号</a:t>
+              </a:r>
+            </a:p>
+          </p:txBody>
+        </p:sp>
+        <p:sp>
+          <p:nvSpPr>
+            <p:cNvPr id="27" name="Compatibility explanation"/>
+            <p:cNvSpPr txBox="1"/>
+            <p:nvPr/>
+          </p:nvSpPr>
+          <p:spPr>
+            <a:xfrm>
+              <a:off x="508000" y="4216400"/>
+              <a:ext cx="2641600" cy="685800"/>
+            </a:xfrm>
+            <a:noFill/>
+          </p:spPr>
+          <p:txBody>
+            <a:bodyPr wrap="none" lIns="0" rIns="0" tIns="0" bIns="0"/>
+            <a:lstStyle/>
+            <a:p>
+              <a:pPr>
+                <a:lnSpc>
+                  <a:spcPts val="2300"/>
+                </a:lnSpc>
+                <a:buAutoNum type="alphaUcParenR" startAt="4"/>
+              </a:pPr>
+              <a:r>
+                <a:rPr sz="1800">
+                  <a:solidFill>
+                    <a:srgbClr val="102238"/>
+                  </a:solidFill>
+                </a:rPr>
+                <a:t>步骤一</a:t>
+              </a:r>
+            </a:p>
+            <a:p>
+              <a:pPr>
+                <a:lnSpc>
+                  <a:spcPts val="2300"/>
+                </a:lnSpc>
+                <a:buAutoNum type="alphaUcParenR"/>
+              </a:pPr>
+              <a:r>
+                <a:rPr sz="1800">
+                  <a:solidFill>
+                    <a:srgbClr val="102238"/>
+                  </a:solidFill>
+                </a:rPr>
+                <a:t>步骤二</a:t>
+              </a:r>
+            </a:p>
+          </p:txBody>
+        </p:sp>
+        <p:sp>
+          <p:nvSpPr>
+            <p:cNvPr id="28" name="Compatibility explanation"/>
+            <p:cNvSpPr txBox="1"/>
+            <p:nvPr/>
+          </p:nvSpPr>
+          <p:spPr>
+            <a:xfrm>
+              <a:off x="3352800" y="3886200"/>
+              <a:ext cx="2641600" cy="304800"/>
+            </a:xfrm>
+            <a:noFill/>
+          </p:spPr>
+          <p:txBody>
+            <a:bodyPr wrap="none" lIns="0" rIns="0" tIns="0" bIns="0"/>
+            <a:lstStyle/>
+            <a:p>
+              <a:r>
+                <a:rPr sz="1600">
+                  <a:solidFill>
+                    <a:srgbClr val="24745C"/>
+                  </a:solidFill>
+                </a:rPr>
+                <a:t>大写字母 · 双括号</a:t>
+              </a:r>
+            </a:p>
+          </p:txBody>
+        </p:sp>
+        <p:sp>
+          <p:nvSpPr>
+            <p:cNvPr id="29" name="Compatibility explanation"/>
+            <p:cNvSpPr txBox="1"/>
+            <p:nvPr/>
+          </p:nvSpPr>
+          <p:spPr>
+            <a:xfrm>
+              <a:off x="3352800" y="4216400"/>
+              <a:ext cx="2641600" cy="685800"/>
+            </a:xfrm>
+            <a:noFill/>
+          </p:spPr>
+          <p:txBody>
+            <a:bodyPr wrap="none" lIns="0" rIns="0" tIns="0" bIns="0"/>
+            <a:lstStyle/>
+            <a:p>
+              <a:pPr>
+                <a:lnSpc>
+                  <a:spcPts val="2300"/>
+                </a:lnSpc>
+                <a:buAutoNum type="alphaUcParenBoth" startAt="4"/>
+              </a:pPr>
+              <a:r>
+                <a:rPr sz="1800">
+                  <a:solidFill>
+                    <a:srgbClr val="102238"/>
+                  </a:solidFill>
+                </a:rPr>
+                <a:t>步骤一</a:t>
+              </a:r>
+            </a:p>
+            <a:p>
+              <a:pPr>
+                <a:lnSpc>
+                  <a:spcPts val="2300"/>
+                </a:lnSpc>
+                <a:buAutoNum type="alphaUcParenBoth"/>
+              </a:pPr>
+              <a:r>
+                <a:rPr sz="1800">
+                  <a:solidFill>
+                    <a:srgbClr val="102238"/>
+                  </a:solidFill>
+                </a:rPr>
+                <a:t>步骤二</a:t>
+              </a:r>
+            </a:p>
+          </p:txBody>
+        </p:sp>
+        <p:sp>
+          <p:nvSpPr>
+            <p:cNvPr id="30" name="Compatibility explanation"/>
+            <p:cNvSpPr txBox="1"/>
+            <p:nvPr/>
+          </p:nvSpPr>
+          <p:spPr>
+            <a:xfrm>
+              <a:off x="6197600" y="3886200"/>
+              <a:ext cx="2641600" cy="304800"/>
+            </a:xfrm>
+            <a:noFill/>
+          </p:spPr>
+          <p:txBody>
+            <a:bodyPr wrap="none" lIns="0" rIns="0" tIns="0" bIns="0"/>
+            <a:lstStyle/>
+            <a:p>
+              <a:r>
+                <a:rPr sz="1600">
+                  <a:solidFill>
+                    <a:srgbClr val="24745C"/>
+                  </a:solidFill>
+                </a:rPr>
+                <a:t>小写罗马 · 句点</a:t>
+              </a:r>
+            </a:p>
+          </p:txBody>
+        </p:sp>
+        <p:sp>
+          <p:nvSpPr>
+            <p:cNvPr id="31" name="Compatibility explanation"/>
+            <p:cNvSpPr txBox="1"/>
+            <p:nvPr/>
+          </p:nvSpPr>
+          <p:spPr>
+            <a:xfrm>
+              <a:off x="6197600" y="4216400"/>
+              <a:ext cx="2641600" cy="685800"/>
+            </a:xfrm>
+            <a:noFill/>
+          </p:spPr>
+          <p:txBody>
+            <a:bodyPr wrap="none" lIns="0" rIns="0" tIns="0" bIns="0"/>
+            <a:lstStyle/>
+            <a:p>
+              <a:pPr>
+                <a:lnSpc>
+                  <a:spcPts val="2300"/>
+                </a:lnSpc>
+                <a:buAutoNum type="romanLcPeriod" startAt="4"/>
+              </a:pPr>
+              <a:r>
+                <a:rPr sz="1800">
+                  <a:solidFill>
+                    <a:srgbClr val="102238"/>
+                  </a:solidFill>
+                </a:rPr>
+                <a:t>步骤一</a:t>
+              </a:r>
+            </a:p>
+            <a:p>
+              <a:pPr>
+                <a:lnSpc>
+                  <a:spcPts val="2300"/>
+                </a:lnSpc>
+                <a:buAutoNum type="romanLcPeriod"/>
+              </a:pPr>
+              <a:r>
+                <a:rPr sz="1800">
+                  <a:solidFill>
+                    <a:srgbClr val="102238"/>
+                  </a:solidFill>
+                </a:rPr>
+                <a:t>步骤二</a:t>
+              </a:r>
+            </a:p>
+          </p:txBody>
+        </p:sp>
+        <p:sp>
+          <p:nvSpPr>
+            <p:cNvPr id="32" name="Compatibility explanation"/>
+            <p:cNvSpPr txBox="1"/>
+            <p:nvPr/>
+          </p:nvSpPr>
+          <p:spPr>
+            <a:xfrm>
+              <a:off x="9042400" y="3886200"/>
+              <a:ext cx="2641600" cy="304800"/>
+            </a:xfrm>
+            <a:noFill/>
+          </p:spPr>
+          <p:txBody>
+            <a:bodyPr wrap="none" lIns="0" rIns="0" tIns="0" bIns="0"/>
+            <a:lstStyle/>
+            <a:p>
+              <a:r>
+                <a:rPr sz="1600">
+                  <a:solidFill>
+                    <a:srgbClr val="24745C"/>
+                  </a:solidFill>
+                </a:rPr>
+                <a:t>小写罗马 · 右括号</a:t>
+              </a:r>
+            </a:p>
+          </p:txBody>
+        </p:sp>
+        <p:sp>
+          <p:nvSpPr>
+            <p:cNvPr id="33" name="Compatibility explanation"/>
+            <p:cNvSpPr txBox="1"/>
+            <p:nvPr/>
+          </p:nvSpPr>
+          <p:spPr>
+            <a:xfrm>
+              <a:off x="9042400" y="4216400"/>
+              <a:ext cx="2641600" cy="685800"/>
+            </a:xfrm>
+            <a:noFill/>
+          </p:spPr>
+          <p:txBody>
+            <a:bodyPr wrap="none" lIns="0" rIns="0" tIns="0" bIns="0"/>
+            <a:lstStyle/>
+            <a:p>
+              <a:pPr>
+                <a:lnSpc>
+                  <a:spcPts val="2300"/>
+                </a:lnSpc>
+                <a:buAutoNum type="romanLcParenR" startAt="4"/>
+              </a:pPr>
+              <a:r>
+                <a:rPr sz="1800">
+                  <a:solidFill>
+                    <a:srgbClr val="102238"/>
+                  </a:solidFill>
+                </a:rPr>
+                <a:t>步骤一</a:t>
+              </a:r>
+            </a:p>
+            <a:p>
+              <a:pPr>
+                <a:lnSpc>
+                  <a:spcPts val="2300"/>
+                </a:lnSpc>
+                <a:buAutoNum type="romanLcParenR"/>
+              </a:pPr>
+              <a:r>
+                <a:rPr sz="1800">
+                  <a:solidFill>
+                    <a:srgbClr val="102238"/>
+                  </a:solidFill>
+                </a:rPr>
+                <a:t>步骤二</a:t>
+              </a:r>
+            </a:p>
+          </p:txBody>
+        </p:sp>
+        <p:sp>
+          <p:nvSpPr>
+            <p:cNvPr id="34" name="Compatibility explanation"/>
+            <p:cNvSpPr txBox="1"/>
+            <p:nvPr/>
+          </p:nvSpPr>
+          <p:spPr>
+            <a:xfrm>
+              <a:off x="508000" y="5029200"/>
+              <a:ext cx="2641600" cy="304800"/>
+            </a:xfrm>
+            <a:noFill/>
+          </p:spPr>
+          <p:txBody>
+            <a:bodyPr wrap="none" lIns="0" rIns="0" tIns="0" bIns="0"/>
+            <a:lstStyle/>
+            <a:p>
+              <a:r>
+                <a:rPr sz="1600">
+                  <a:solidFill>
+                    <a:srgbClr val="24745C"/>
+                  </a:solidFill>
+                </a:rPr>
+                <a:t>小写罗马 · 双括号</a:t>
+              </a:r>
+            </a:p>
+          </p:txBody>
+        </p:sp>
+        <p:sp>
+          <p:nvSpPr>
+            <p:cNvPr id="35" name="Compatibility explanation"/>
+            <p:cNvSpPr txBox="1"/>
+            <p:nvPr/>
+          </p:nvSpPr>
+          <p:spPr>
+            <a:xfrm>
+              <a:off x="508000" y="5359400"/>
+              <a:ext cx="2641600" cy="685800"/>
+            </a:xfrm>
+            <a:noFill/>
+          </p:spPr>
+          <p:txBody>
+            <a:bodyPr wrap="none" lIns="0" rIns="0" tIns="0" bIns="0"/>
+            <a:lstStyle/>
+            <a:p>
+              <a:pPr>
+                <a:lnSpc>
+                  <a:spcPts val="2300"/>
+                </a:lnSpc>
+                <a:buAutoNum type="romanLcParenBoth" startAt="4"/>
+              </a:pPr>
+              <a:r>
+                <a:rPr sz="1800">
+                  <a:solidFill>
+                    <a:srgbClr val="102238"/>
+                  </a:solidFill>
+                </a:rPr>
+                <a:t>步骤一</a:t>
+              </a:r>
+            </a:p>
+            <a:p>
+              <a:pPr>
+                <a:lnSpc>
+                  <a:spcPts val="2300"/>
+                </a:lnSpc>
+                <a:buAutoNum type="romanLcParenBoth"/>
+              </a:pPr>
+              <a:r>
+                <a:rPr sz="1800">
+                  <a:solidFill>
+                    <a:srgbClr val="102238"/>
+                  </a:solidFill>
+                </a:rPr>
+                <a:t>步骤二</a:t>
+              </a:r>
+            </a:p>
+          </p:txBody>
+        </p:sp>
+        <p:sp>
+          <p:nvSpPr>
+            <p:cNvPr id="36" name="Compatibility explanation"/>
+            <p:cNvSpPr txBox="1"/>
+            <p:nvPr/>
+          </p:nvSpPr>
+          <p:spPr>
+            <a:xfrm>
+              <a:off x="3352800" y="5029200"/>
+              <a:ext cx="2641600" cy="304800"/>
+            </a:xfrm>
+            <a:noFill/>
+          </p:spPr>
+          <p:txBody>
+            <a:bodyPr wrap="none" lIns="0" rIns="0" tIns="0" bIns="0"/>
+            <a:lstStyle/>
+            <a:p>
+              <a:r>
+                <a:rPr sz="1600">
+                  <a:solidFill>
+                    <a:srgbClr val="24745C"/>
+                  </a:solidFill>
+                </a:rPr>
+                <a:t>大写罗马 · 句点</a:t>
+              </a:r>
+            </a:p>
+          </p:txBody>
+        </p:sp>
+        <p:sp>
+          <p:nvSpPr>
+            <p:cNvPr id="37" name="Compatibility explanation"/>
+            <p:cNvSpPr txBox="1"/>
+            <p:nvPr/>
+          </p:nvSpPr>
+          <p:spPr>
+            <a:xfrm>
+              <a:off x="3352800" y="5359400"/>
+              <a:ext cx="2641600" cy="685800"/>
+            </a:xfrm>
+            <a:noFill/>
+          </p:spPr>
+          <p:txBody>
+            <a:bodyPr wrap="none" lIns="0" rIns="0" tIns="0" bIns="0"/>
+            <a:lstStyle/>
+            <a:p>
+              <a:pPr>
+                <a:lnSpc>
+                  <a:spcPts val="2300"/>
+                </a:lnSpc>
+                <a:buAutoNum type="romanUcPeriod" startAt="4"/>
+              </a:pPr>
+              <a:r>
+                <a:rPr sz="1800">
+                  <a:solidFill>
+                    <a:srgbClr val="102238"/>
+                  </a:solidFill>
+                </a:rPr>
+                <a:t>步骤一</a:t>
+              </a:r>
+            </a:p>
+            <a:p>
+              <a:pPr>
+                <a:lnSpc>
+                  <a:spcPts val="2300"/>
+                </a:lnSpc>
+                <a:buAutoNum type="romanUcPeriod"/>
+              </a:pPr>
+              <a:r>
+                <a:rPr sz="1800">
+                  <a:solidFill>
+                    <a:srgbClr val="102238"/>
+                  </a:solidFill>
+                </a:rPr>
+                <a:t>步骤二</a:t>
+              </a:r>
+            </a:p>
+          </p:txBody>
+        </p:sp>
+        <p:sp>
+          <p:nvSpPr>
+            <p:cNvPr id="38" name="Compatibility explanation"/>
+            <p:cNvSpPr txBox="1"/>
+            <p:nvPr/>
+          </p:nvSpPr>
+          <p:spPr>
+            <a:xfrm>
+              <a:off x="6197600" y="5029200"/>
+              <a:ext cx="2641600" cy="304800"/>
+            </a:xfrm>
+            <a:noFill/>
+          </p:spPr>
+          <p:txBody>
+            <a:bodyPr wrap="none" lIns="0" rIns="0" tIns="0" bIns="0"/>
+            <a:lstStyle/>
+            <a:p>
+              <a:r>
+                <a:rPr sz="1600">
+                  <a:solidFill>
+                    <a:srgbClr val="24745C"/>
+                  </a:solidFill>
+                </a:rPr>
+                <a:t>大写罗马 · 右括号</a:t>
+              </a:r>
+            </a:p>
+          </p:txBody>
+        </p:sp>
+        <p:sp>
+          <p:nvSpPr>
+            <p:cNvPr id="39" name="Compatibility explanation"/>
+            <p:cNvSpPr txBox="1"/>
+            <p:nvPr/>
+          </p:nvSpPr>
+          <p:spPr>
+            <a:xfrm>
+              <a:off x="6197600" y="5359400"/>
+              <a:ext cx="2641600" cy="685800"/>
+            </a:xfrm>
+            <a:noFill/>
+          </p:spPr>
+          <p:txBody>
+            <a:bodyPr wrap="none" lIns="0" rIns="0" tIns="0" bIns="0"/>
+            <a:lstStyle/>
+            <a:p>
+              <a:pPr>
+                <a:lnSpc>
+                  <a:spcPts val="2300"/>
+                </a:lnSpc>
+                <a:buAutoNum type="romanUcParenR" startAt="4"/>
+              </a:pPr>
+              <a:r>
+                <a:rPr sz="1800">
+                  <a:solidFill>
+                    <a:srgbClr val="102238"/>
+                  </a:solidFill>
+                </a:rPr>
+                <a:t>步骤一</a:t>
+              </a:r>
+            </a:p>
+            <a:p>
+              <a:pPr>
+                <a:lnSpc>
+                  <a:spcPts val="2300"/>
+                </a:lnSpc>
+                <a:buAutoNum type="romanUcParenR"/>
+              </a:pPr>
+              <a:r>
+                <a:rPr sz="1800">
+                  <a:solidFill>
+                    <a:srgbClr val="102238"/>
+                  </a:solidFill>
+                </a:rPr>
+                <a:t>步骤二</a:t>
+              </a:r>
+            </a:p>
+          </p:txBody>
+        </p:sp>
+        <p:sp>
+          <p:nvSpPr>
+            <p:cNvPr id="40" name="Compatibility explanation"/>
+            <p:cNvSpPr txBox="1"/>
+            <p:nvPr/>
+          </p:nvSpPr>
+          <p:spPr>
+            <a:xfrm>
+              <a:off x="9042400" y="5029200"/>
+              <a:ext cx="2641600" cy="304800"/>
+            </a:xfrm>
+            <a:noFill/>
+          </p:spPr>
+          <p:txBody>
+            <a:bodyPr wrap="none" lIns="0" rIns="0" tIns="0" bIns="0"/>
+            <a:lstStyle/>
+            <a:p>
+              <a:r>
+                <a:rPr sz="1600">
+                  <a:solidFill>
+                    <a:srgbClr val="24745C"/>
+                  </a:solidFill>
+                </a:rPr>
+                <a:t>大写罗马 · 双括号</a:t>
+              </a:r>
+            </a:p>
+          </p:txBody>
+        </p:sp>
+        <p:sp>
+          <p:nvSpPr>
+            <p:cNvPr id="41" name="Compatibility explanation"/>
+            <p:cNvSpPr txBox="1"/>
+            <p:nvPr/>
+          </p:nvSpPr>
+          <p:spPr>
+            <a:xfrm>
+              <a:off x="9042400" y="5359400"/>
+              <a:ext cx="2641600" cy="685800"/>
+            </a:xfrm>
+            <a:noFill/>
+          </p:spPr>
+          <p:txBody>
+            <a:bodyPr wrap="none" lIns="0" rIns="0" tIns="0" bIns="0"/>
+            <a:lstStyle/>
+            <a:p>
+              <a:pPr>
+                <a:lnSpc>
+                  <a:spcPts val="2300"/>
+                </a:lnSpc>
+                <a:buAutoNum type="romanUcParenBoth" startAt="4"/>
+              </a:pPr>
+              <a:r>
+                <a:rPr sz="1800">
+                  <a:solidFill>
+                    <a:srgbClr val="102238"/>
+                  </a:solidFill>
+                </a:rPr>
+                <a:t>步骤一</a:t>
+              </a:r>
+            </a:p>
+            <a:p>
+              <a:pPr>
+                <a:lnSpc>
+                  <a:spcPts val="2300"/>
+                </a:lnSpc>
+                <a:buAutoNum type="romanUcParenBoth"/>
+              </a:pPr>
+              <a:r>
+                <a:rPr sz="1800">
+                  <a:solidFill>
+                    <a:srgbClr val="102238"/>
+                  </a:solidFill>
+                </a:rPr>
+                <a:t>步骤二</a:t>
+              </a:r>
+            </a:p>
+          </p:txBody>
+        </p:sp>
+        <p:sp>
+          <p:nvSpPr>
+            <p:cNvPr id="4" name="Compatibility explanation"/>
+            <p:cNvSpPr txBox="1"/>
+            <p:nvPr/>
+          </p:nvSpPr>
+          <p:spPr>
+            <a:xfrm>
+              <a:off x="508000" y="6375400"/>
+              <a:ext cx="11176000" cy="304800"/>
+            </a:xfrm>
+            <a:noFill/>
+          </p:spPr>
+          <p:txBody>
+            <a:bodyPr wrap="none" lIns="0" rIns="0" tIns="0" bIns="0"/>
+            <a:lstStyle/>
+            <a:p>
+              <a:r>
+                <a:rPr sz="1600">
+                  <a:solidFill>
+                    <a:srgbClr val="102238"/>
+                  </a:solidFill>
+                </a:rPr>
+                <a:t>预期：编号依次为 4/5、d/e、D/E、iv/v 或 IV/V，标点保持各组格式。</a:t>
+              </a:r>
+            </a:p>
+          </p:txBody>
+        </p:sp>
+      </p:grpSp>
+    </p:spTree>
+  </p:cSld>
+</p:sld>
+</file>
+
+<file path=ppt/showcase/compatibility/theme/theme1.xml><?xml version="1.0" encoding="utf-8"?>
+<a:theme xmlns:a="http://schemas.openxmlformats.org/drawingml/2006/main" name="Fixture theme">
+  <a:themeElements>
+    <a:clrScheme name="Fixture colors">
+      <a:dk1>
+        <a:srgbClr val="202124"/>
+      </a:dk1>
+      <a:lt1>
+        <a:srgbClr val="FFFFFF"/>
+      </a:lt1>
+      <a:dk2>
+        <a:srgbClr val="112233"/>
+      </a:dk2>
+      <a:lt2>
+        <a:srgbClr val="F4F7FA"/>
+      </a:lt2>
+      <a:accent1>
+        <a:srgbClr val="2A9D8F"/>
+      </a:accent1>
+      <a:accent2>
+        <a:srgbClr val="E9C46A"/>
+      </a:accent2>
+      <a:accent3>
+        <a:srgbClr val="E76F51"/>
+      </a:accent3>
+      <a:accent4>
+        <a:srgbClr val="457B9D"/>
+      </a:accent4>
+      <a:accent5>
+        <a:srgbClr val="8F5D9F"/>
+      </a:accent5>
+      <a:accent6>
+        <a:srgbClr val="6A994E"/>
+      </a:accent6>
+      <a:hlink>
+        <a:srgbClr val="0563C1"/>
+      </a:hlink>
+      <a:folHlink>
+        <a:srgbClr val="954F72"/>
+      </a:folHlink>
+    </a:clrScheme>
+    <a:fontScheme name="Fixture fonts">
+      <a:majorFont>
+        <a:latin typeface="Arial"/>
+        <a:ea typeface=""/>
+        <a:cs typeface=""/>
+        <a:font script="Hans" typeface="Microsoft YaHei"/>
+      </a:majorFont>
+      <a:minorFont>
+        <a:latin typeface="Arial"/>
+        <a:ea typeface=""/>
+        <a:cs typeface=""/>
+        <a:font script="Hans" typeface="Microsoft YaHei"/>
+      </a:minorFont>
+    </a:fontScheme>
+    <a:fmtScheme name="Fixture format">
+      <a:fillStyleLst>
+        <a:solidFill>
+          <a:schemeClr val="phClr"/>
+        </a:solidFill>
+        <a:solidFill>
+          <a:schemeClr val="phClr"/>
+        </a:solidFill>
+        <a:solidFill>
+          <a:schemeClr val="phClr"/>
+        </a:solidFill>
+      </a:fillStyleLst>
+      <a:lnStyleLst>
+        <a:ln w="12700" cap="flat" cmpd="sng" algn="ctr">
+          <a:solidFill>
+            <a:schemeClr val="phClr"/>
+          </a:solidFill>
+          <a:prstDash val="solid"/>
+          <a:miter lim="800000"/>
+          <a:headEnd type="none" w="med" len="med"/>
+          <a:tailEnd type="none" w="med" len="med"/>
+        </a:ln>
+        <a:ln w="25400" cap="flat" cmpd="sng" algn="ctr">
+          <a:solidFill>
+            <a:schemeClr val="phClr"/>
+          </a:solidFill>
+          <a:prstDash val="solid"/>
+          <a:miter lim="800000"/>
+          <a:headEnd type="none" w="med" len="med"/>
+          <a:tailEnd type="none" w="med" len="med"/>
+        </a:ln>
+        <a:ln w="38100" cap="flat" cmpd="sng" algn="ctr">
+          <a:solidFill>
+            <a:schemeClr val="phClr"/>
+          </a:solidFill>
+          <a:prstDash val="solid"/>
+          <a:miter lim="800000"/>
+          <a:headEnd type="none" w="med" len="med"/>
+          <a:tailEnd type="none" w="med" len="med"/>
+        </a:ln>
+      </a:lnStyleLst>
+      <a:effectStyleLst>
+        <a:effectStyle>
+          <a:effectLst/>
+        </a:effectStyle>
+        <a:effectStyle>
+          <a:effectLst/>
+        </a:effectStyle>
+        <a:effectStyle>
+          <a:effectLst/>
+        </a:effectStyle>
+      </a:effectStyleLst>
+      <a:bgFillStyleLst>
+        <a:solidFill>
+          <a:schemeClr val="phClr"/>
+        </a:solidFill>
+        <a:solidFill>
+          <a:schemeClr val="phClr"/>
+        </a:solidFill>
+        <a:solidFill>
+          <a:schemeClr val="phClr"/>
+        </a:solidFill>
+      </a:bgFillStyleLst>
+    </a:fmtScheme>
+  </a:themeElements>
+</a:theme>
+</file>
+
 <file path=ppt/showcase/typography/slideLayouts/slideLayout1.xml><?xml version="1.0" encoding="utf-8"?>
 <p:sldLayout xmlns:p="http://schemas.openxmlformats.org/presentationml/2006/main" xmlns:a="http://schemas.openxmlformats.org/drawingml/2006/main" type="blank" preserve="1">
   <p:cSld name="Blank">
@@ -7428,7 +9578,7 @@
             </a:pPr>
             <a:r>
               <a:rPr sz="1800"/>
-              <a:t>7 组主题，15 页样例。按展示条件核对预期效果，细节可放大查看。</a:t>
+              <a:t>8 组主题，17 页样例。按展示条件核对预期效果，细节可放大查看。</a:t>
             </a:r>
           </a:p>
           <a:p>
@@ -7508,6 +9658,17 @@
               <a:t>14-16    背景：继承、透明图片与图形变换</a:t>
             </a:r>
           </a:p>
+          <a:p>
+            <a:pPr>
+              <a:spcAft>
+                <a:spcPts val="1400"/>
+              </a:spcAft>
+            </a:pPr>
+            <a:r>
+              <a:rPr sz="2200"/>
+              <a:t>17-18    兼容补充：自动编号与预设图形</a:t>
+            </a:r>
+          </a:p>
         </p:txBody>
       </p:sp>
     </p:spTree>

</xml_diff>